<commit_message>
fix: correct slide layout to LAYOUT_4x3 (10x7.5in) in all 3 Amazon CEO decks
LAYOUT_16x9 in PptxGenJS is 10x5.625in, causing bottom elements to overflow
the slide boundary. LAYOUT_4x3 matches the 10x7.5in coordinate system used.

Co-Authored-By: Claude Sonnet 4.6 <noreply@anthropic.com>
</commit_message>
<xml_diff>
--- a/assets/amazon-checkoutlift-deck.pptx
+++ b/assets/amazon-checkoutlift-deck.pptx
@@ -17,8 +17,8 @@
   <p:notesMasterIdLst>
     <p:notesMasterId r:id="rId10"/>
   </p:notesMasterIdLst>
-  <p:sldSz cx="9144000" cy="5143500"/>
-  <p:notesSz cx="5143500" cy="9144000"/>
+  <p:sldSz cx="9144000" cy="6858000"/>
+  <p:notesSz cx="6858000" cy="9144000"/>
   <p:defaultTextStyle>
     <a:lvl1pPr marL="0" algn="l" defTabSz="914400" rtl="0" eaLnBrk="1" latinLnBrk="0" hangingPunct="1">
       <a:defRPr sz="1800" kern="1200">

</xml_diff>